<commit_message>
Fix all PPTX layout overlaps: shrink KPI cards, reposition savings table & summary cards
- Slide 1: Re-center KPI cards with narrower 2.2in width
- Slide 9: Move right KPI column from x=11.8 to x=11.0 (was overflowing 13.3in slide)
- Slide 10: Reposition savings callout to x=9.6
- Slide 11: Shrink table columns (total width 7.75in -> 8.05in), move summary card to x=8.2
- All elements verified within 13.333in slide bounds
</commit_message>
<xml_diff>
--- a/output/Informatica_to_Fabric_Migration_Tool_v2.pptx
+++ b/output/Informatica_to_Fabric_Migration_Tool_v2.pptx
@@ -3185,8 +3185,8 @@
         </p:nvSpPr>
         <p:spPr>
           <a:xfrm>
-            <a:off x="1005840" y="3657600"/>
-            <a:ext cx="2377440" cy="1371600"/>
+            <a:off x="1371600" y="3657600"/>
+            <a:ext cx="2011680" cy="1371600"/>
           </a:xfrm>
           <a:prstGeom prst="roundRect">
             <a:avLst/>
@@ -3229,8 +3229,8 @@
         </p:nvSpPr>
         <p:spPr>
           <a:xfrm>
-            <a:off x="1097280" y="3794760"/>
-            <a:ext cx="2194560" cy="731520"/>
+            <a:off x="1417320" y="3794760"/>
+            <a:ext cx="1920240" cy="731520"/>
           </a:xfrm>
           <a:prstGeom prst="rect">
             <a:avLst/>
@@ -3245,7 +3245,7 @@
           <a:p>
             <a:pPr algn="ctr"/>
             <a:r>
-              <a:rPr sz="3600" b="1">
+              <a:rPr sz="3200" b="1">
                 <a:solidFill>
                   <a:srgbClr val="FFFFFF"/>
                 </a:solidFill>
@@ -3263,8 +3263,8 @@
         </p:nvSpPr>
         <p:spPr>
           <a:xfrm>
-            <a:off x="1097280" y="4434840"/>
-            <a:ext cx="2194560" cy="457200"/>
+            <a:off x="1417320" y="4434840"/>
+            <a:ext cx="1920240" cy="457200"/>
           </a:xfrm>
           <a:prstGeom prst="rect">
             <a:avLst/>
@@ -3279,7 +3279,7 @@
           <a:p>
             <a:pPr algn="ctr"/>
             <a:r>
-              <a:rPr sz="1300" b="0">
+              <a:rPr sz="1200" b="0">
                 <a:solidFill>
                   <a:srgbClr val="FFFFFF"/>
                 </a:solidFill>
@@ -3297,8 +3297,8 @@
         </p:nvSpPr>
         <p:spPr>
           <a:xfrm>
-            <a:off x="3703320" y="3657600"/>
-            <a:ext cx="2377440" cy="1371600"/>
+            <a:off x="3749040" y="3657600"/>
+            <a:ext cx="2011680" cy="1371600"/>
           </a:xfrm>
           <a:prstGeom prst="roundRect">
             <a:avLst/>
@@ -3342,7 +3342,7 @@
         <p:spPr>
           <a:xfrm>
             <a:off x="3794760" y="3794760"/>
-            <a:ext cx="2194560" cy="731520"/>
+            <a:ext cx="1920240" cy="731520"/>
           </a:xfrm>
           <a:prstGeom prst="rect">
             <a:avLst/>
@@ -3357,7 +3357,7 @@
           <a:p>
             <a:pPr algn="ctr"/>
             <a:r>
-              <a:rPr sz="3600" b="1">
+              <a:rPr sz="3200" b="1">
                 <a:solidFill>
                   <a:srgbClr val="FFFFFF"/>
                 </a:solidFill>
@@ -3376,7 +3376,7 @@
         <p:spPr>
           <a:xfrm>
             <a:off x="3794760" y="4434840"/>
-            <a:ext cx="2194560" cy="457200"/>
+            <a:ext cx="1920240" cy="457200"/>
           </a:xfrm>
           <a:prstGeom prst="rect">
             <a:avLst/>
@@ -3391,7 +3391,7 @@
           <a:p>
             <a:pPr algn="ctr"/>
             <a:r>
-              <a:rPr sz="1300" b="0">
+              <a:rPr sz="1200" b="0">
                 <a:solidFill>
                   <a:srgbClr val="FFFFFF"/>
                 </a:solidFill>
@@ -3409,8 +3409,8 @@
         </p:nvSpPr>
         <p:spPr>
           <a:xfrm>
-            <a:off x="6400800" y="3657600"/>
-            <a:ext cx="2377440" cy="1371600"/>
+            <a:off x="6126480" y="3657600"/>
+            <a:ext cx="2011680" cy="1371600"/>
           </a:xfrm>
           <a:prstGeom prst="roundRect">
             <a:avLst/>
@@ -3453,8 +3453,8 @@
         </p:nvSpPr>
         <p:spPr>
           <a:xfrm>
-            <a:off x="6492240" y="3794760"/>
-            <a:ext cx="2194560" cy="731520"/>
+            <a:off x="6172200" y="3794760"/>
+            <a:ext cx="1920240" cy="731520"/>
           </a:xfrm>
           <a:prstGeom prst="rect">
             <a:avLst/>
@@ -3469,7 +3469,7 @@
           <a:p>
             <a:pPr algn="ctr"/>
             <a:r>
-              <a:rPr sz="3600" b="1">
+              <a:rPr sz="3200" b="1">
                 <a:solidFill>
                   <a:srgbClr val="FFFFFF"/>
                 </a:solidFill>
@@ -3487,8 +3487,8 @@
         </p:nvSpPr>
         <p:spPr>
           <a:xfrm>
-            <a:off x="6492240" y="4434840"/>
-            <a:ext cx="2194560" cy="457200"/>
+            <a:off x="6172200" y="4434840"/>
+            <a:ext cx="1920240" cy="457200"/>
           </a:xfrm>
           <a:prstGeom prst="rect">
             <a:avLst/>
@@ -3503,7 +3503,7 @@
           <a:p>
             <a:pPr algn="ctr"/>
             <a:r>
-              <a:rPr sz="1300" b="0">
+              <a:rPr sz="1200" b="0">
                 <a:solidFill>
                   <a:srgbClr val="FFFFFF"/>
                 </a:solidFill>
@@ -3521,8 +3521,8 @@
         </p:nvSpPr>
         <p:spPr>
           <a:xfrm>
-            <a:off x="9098280" y="3657600"/>
-            <a:ext cx="2377440" cy="1371600"/>
+            <a:off x="8503920" y="3657600"/>
+            <a:ext cx="2011680" cy="1371600"/>
           </a:xfrm>
           <a:prstGeom prst="roundRect">
             <a:avLst/>
@@ -3565,8 +3565,8 @@
         </p:nvSpPr>
         <p:spPr>
           <a:xfrm>
-            <a:off x="9189720" y="3794760"/>
-            <a:ext cx="2194560" cy="731520"/>
+            <a:off x="8549640" y="3794760"/>
+            <a:ext cx="1920240" cy="731520"/>
           </a:xfrm>
           <a:prstGeom prst="rect">
             <a:avLst/>
@@ -3581,7 +3581,7 @@
           <a:p>
             <a:pPr algn="ctr"/>
             <a:r>
-              <a:rPr sz="3600" b="1">
+              <a:rPr sz="3200" b="1">
                 <a:solidFill>
                   <a:srgbClr val="FFFFFF"/>
                 </a:solidFill>
@@ -3599,8 +3599,8 @@
         </p:nvSpPr>
         <p:spPr>
           <a:xfrm>
-            <a:off x="9189720" y="4434840"/>
-            <a:ext cx="2194560" cy="457200"/>
+            <a:off x="8549640" y="4434840"/>
+            <a:ext cx="1920240" cy="457200"/>
           </a:xfrm>
           <a:prstGeom prst="rect">
             <a:avLst/>
@@ -3615,7 +3615,7 @@
           <a:p>
             <a:pPr algn="ctr"/>
             <a:r>
-              <a:rPr sz="1300" b="0">
+              <a:rPr sz="1200" b="0">
                 <a:solidFill>
                   <a:srgbClr val="FFFFFF"/>
                 </a:solidFill>
@@ -4463,8 +4463,8 @@
         </p:nvSpPr>
         <p:spPr>
           <a:xfrm>
-            <a:off x="7772400" y="3931920"/>
-            <a:ext cx="3931920" cy="2286000"/>
+            <a:off x="8778240" y="3931920"/>
+            <a:ext cx="3108960" cy="2286000"/>
           </a:xfrm>
           <a:prstGeom prst="roundRect">
             <a:avLst/>
@@ -4497,7 +4497,7 @@
           <a:p>
             <a:pPr algn="ctr"/>
             <a:r>
-              <a:rPr sz="1600" b="0">
+              <a:rPr sz="1500" b="0">
                 <a:solidFill>
                   <a:srgbClr val="FFFFFF"/>
                 </a:solidFill>
@@ -4659,7 +4659,7 @@
         <p:spPr>
           <a:xfrm>
             <a:off x="274320" y="1417320"/>
-            <a:ext cx="2468880" cy="502920"/>
+            <a:ext cx="2194560" cy="502920"/>
           </a:xfrm>
           <a:prstGeom prst="roundRect">
             <a:avLst/>
@@ -4710,8 +4710,8 @@
         </p:nvSpPr>
         <p:spPr>
           <a:xfrm>
-            <a:off x="2743200" y="1417320"/>
-            <a:ext cx="1143000" cy="502920"/>
+            <a:off x="2468880" y="1417320"/>
+            <a:ext cx="822960" cy="502920"/>
           </a:xfrm>
           <a:prstGeom prst="roundRect">
             <a:avLst/>
@@ -4750,7 +4750,7 @@
                 </a:solidFill>
               </a:rPr>
               <a:t>Manual
-(hours/item)</a:t>
+(h/item)</a:t>
             </a:r>
           </a:p>
         </p:txBody>
@@ -4763,8 +4763,8 @@
         </p:nvSpPr>
         <p:spPr>
           <a:xfrm>
-            <a:off x="3886200" y="1417320"/>
-            <a:ext cx="1143000" cy="502920"/>
+            <a:off x="3291840" y="1417320"/>
+            <a:ext cx="822960" cy="502920"/>
           </a:xfrm>
           <a:prstGeom prst="roundRect">
             <a:avLst/>
@@ -4802,8 +4802,8 @@
                   <a:srgbClr val="FFFFFF"/>
                 </a:solidFill>
               </a:rPr>
-              <a:t>Automated
-(hours/item)</a:t>
+              <a:t>Auto
+(h/item)</a:t>
             </a:r>
           </a:p>
         </p:txBody>
@@ -4816,8 +4816,8 @@
         </p:nvSpPr>
         <p:spPr>
           <a:xfrm>
-            <a:off x="5029200" y="1417320"/>
-            <a:ext cx="685800" cy="502920"/>
+            <a:off x="4114800" y="1417320"/>
+            <a:ext cx="548640" cy="502920"/>
           </a:xfrm>
           <a:prstGeom prst="roundRect">
             <a:avLst/>
@@ -4868,8 +4868,8 @@
         </p:nvSpPr>
         <p:spPr>
           <a:xfrm>
-            <a:off x="5715000" y="1417320"/>
-            <a:ext cx="1143000" cy="502920"/>
+            <a:off x="4663440" y="1417320"/>
+            <a:ext cx="960120" cy="502920"/>
           </a:xfrm>
           <a:prstGeom prst="roundRect">
             <a:avLst/>
@@ -4921,8 +4921,8 @@
         </p:nvSpPr>
         <p:spPr>
           <a:xfrm>
-            <a:off x="6858000" y="1417320"/>
-            <a:ext cx="1143000" cy="502920"/>
+            <a:off x="5623560" y="1417320"/>
+            <a:ext cx="960120" cy="502920"/>
           </a:xfrm>
           <a:prstGeom prst="roundRect">
             <a:avLst/>
@@ -4960,7 +4960,7 @@
                   <a:srgbClr val="FFFFFF"/>
                 </a:solidFill>
               </a:rPr>
-              <a:t>Automated
+              <a:t>Auto
 Total (h)</a:t>
             </a:r>
           </a:p>
@@ -4974,8 +4974,8 @@
         </p:nvSpPr>
         <p:spPr>
           <a:xfrm>
-            <a:off x="8001000" y="1417320"/>
-            <a:ext cx="1005840" cy="502920"/>
+            <a:off x="6583680" y="1417320"/>
+            <a:ext cx="777240" cy="502920"/>
           </a:xfrm>
           <a:prstGeom prst="roundRect">
             <a:avLst/>
@@ -5013,7 +5013,7 @@
                   <a:srgbClr val="FFFFFF"/>
                 </a:solidFill>
               </a:rPr>
-              <a:t>Savings</a:t>
+              <a:t>Saved</a:t>
             </a:r>
           </a:p>
         </p:txBody>
@@ -5027,7 +5027,7 @@
         <p:spPr>
           <a:xfrm>
             <a:off x="274320" y="1801368"/>
-            <a:ext cx="2468880" cy="347472"/>
+            <a:ext cx="2194560" cy="347472"/>
           </a:xfrm>
           <a:prstGeom prst="roundRect">
             <a:avLst/>
@@ -5078,8 +5078,8 @@
         </p:nvSpPr>
         <p:spPr>
           <a:xfrm>
-            <a:off x="2743200" y="1801368"/>
-            <a:ext cx="1143000" cy="347472"/>
+            <a:off x="2468880" y="1801368"/>
+            <a:ext cx="822960" cy="347472"/>
           </a:xfrm>
           <a:prstGeom prst="roundRect">
             <a:avLst/>
@@ -5130,8 +5130,8 @@
         </p:nvSpPr>
         <p:spPr>
           <a:xfrm>
-            <a:off x="3886200" y="1801368"/>
-            <a:ext cx="1143000" cy="347472"/>
+            <a:off x="3291840" y="1801368"/>
+            <a:ext cx="822960" cy="347472"/>
           </a:xfrm>
           <a:prstGeom prst="roundRect">
             <a:avLst/>
@@ -5182,8 +5182,8 @@
         </p:nvSpPr>
         <p:spPr>
           <a:xfrm>
-            <a:off x="5029200" y="1801368"/>
-            <a:ext cx="685800" cy="347472"/>
+            <a:off x="4114800" y="1801368"/>
+            <a:ext cx="548640" cy="347472"/>
           </a:xfrm>
           <a:prstGeom prst="roundRect">
             <a:avLst/>
@@ -5234,8 +5234,8 @@
         </p:nvSpPr>
         <p:spPr>
           <a:xfrm>
-            <a:off x="5715000" y="1801368"/>
-            <a:ext cx="1143000" cy="347472"/>
+            <a:off x="4663440" y="1801368"/>
+            <a:ext cx="960120" cy="347472"/>
           </a:xfrm>
           <a:prstGeom prst="roundRect">
             <a:avLst/>
@@ -5286,8 +5286,8 @@
         </p:nvSpPr>
         <p:spPr>
           <a:xfrm>
-            <a:off x="6858000" y="1801368"/>
-            <a:ext cx="1143000" cy="347472"/>
+            <a:off x="5623560" y="1801368"/>
+            <a:ext cx="960120" cy="347472"/>
           </a:xfrm>
           <a:prstGeom prst="roundRect">
             <a:avLst/>
@@ -5338,8 +5338,8 @@
         </p:nvSpPr>
         <p:spPr>
           <a:xfrm>
-            <a:off x="8001000" y="1801368"/>
-            <a:ext cx="1005840" cy="347472"/>
+            <a:off x="6583680" y="1801368"/>
+            <a:ext cx="777240" cy="347472"/>
           </a:xfrm>
           <a:prstGeom prst="roundRect">
             <a:avLst/>
@@ -5391,7 +5391,7 @@
         <p:spPr>
           <a:xfrm>
             <a:off x="274320" y="2185416"/>
-            <a:ext cx="2468880" cy="347472"/>
+            <a:ext cx="2194560" cy="347472"/>
           </a:xfrm>
           <a:prstGeom prst="roundRect">
             <a:avLst/>
@@ -5442,8 +5442,8 @@
         </p:nvSpPr>
         <p:spPr>
           <a:xfrm>
-            <a:off x="2743200" y="2185416"/>
-            <a:ext cx="1143000" cy="347472"/>
+            <a:off x="2468880" y="2185416"/>
+            <a:ext cx="822960" cy="347472"/>
           </a:xfrm>
           <a:prstGeom prst="roundRect">
             <a:avLst/>
@@ -5494,8 +5494,8 @@
         </p:nvSpPr>
         <p:spPr>
           <a:xfrm>
-            <a:off x="3886200" y="2185416"/>
-            <a:ext cx="1143000" cy="347472"/>
+            <a:off x="3291840" y="2185416"/>
+            <a:ext cx="822960" cy="347472"/>
           </a:xfrm>
           <a:prstGeom prst="roundRect">
             <a:avLst/>
@@ -5546,8 +5546,8 @@
         </p:nvSpPr>
         <p:spPr>
           <a:xfrm>
-            <a:off x="5029200" y="2185416"/>
-            <a:ext cx="685800" cy="347472"/>
+            <a:off x="4114800" y="2185416"/>
+            <a:ext cx="548640" cy="347472"/>
           </a:xfrm>
           <a:prstGeom prst="roundRect">
             <a:avLst/>
@@ -5598,8 +5598,8 @@
         </p:nvSpPr>
         <p:spPr>
           <a:xfrm>
-            <a:off x="5715000" y="2185416"/>
-            <a:ext cx="1143000" cy="347472"/>
+            <a:off x="4663440" y="2185416"/>
+            <a:ext cx="960120" cy="347472"/>
           </a:xfrm>
           <a:prstGeom prst="roundRect">
             <a:avLst/>
@@ -5650,8 +5650,8 @@
         </p:nvSpPr>
         <p:spPr>
           <a:xfrm>
-            <a:off x="6858000" y="2185416"/>
-            <a:ext cx="1143000" cy="347472"/>
+            <a:off x="5623560" y="2185416"/>
+            <a:ext cx="960120" cy="347472"/>
           </a:xfrm>
           <a:prstGeom prst="roundRect">
             <a:avLst/>
@@ -5702,8 +5702,8 @@
         </p:nvSpPr>
         <p:spPr>
           <a:xfrm>
-            <a:off x="8001000" y="2185416"/>
-            <a:ext cx="1005840" cy="347472"/>
+            <a:off x="6583680" y="2185416"/>
+            <a:ext cx="777240" cy="347472"/>
           </a:xfrm>
           <a:prstGeom prst="roundRect">
             <a:avLst/>
@@ -5755,7 +5755,7 @@
         <p:spPr>
           <a:xfrm>
             <a:off x="274320" y="2569464"/>
-            <a:ext cx="2468880" cy="347472"/>
+            <a:ext cx="2194560" cy="347472"/>
           </a:xfrm>
           <a:prstGeom prst="roundRect">
             <a:avLst/>
@@ -5806,8 +5806,8 @@
         </p:nvSpPr>
         <p:spPr>
           <a:xfrm>
-            <a:off x="2743200" y="2569464"/>
-            <a:ext cx="1143000" cy="347472"/>
+            <a:off x="2468880" y="2569464"/>
+            <a:ext cx="822960" cy="347472"/>
           </a:xfrm>
           <a:prstGeom prst="roundRect">
             <a:avLst/>
@@ -5858,8 +5858,8 @@
         </p:nvSpPr>
         <p:spPr>
           <a:xfrm>
-            <a:off x="3886200" y="2569464"/>
-            <a:ext cx="1143000" cy="347472"/>
+            <a:off x="3291840" y="2569464"/>
+            <a:ext cx="822960" cy="347472"/>
           </a:xfrm>
           <a:prstGeom prst="roundRect">
             <a:avLst/>
@@ -5910,8 +5910,8 @@
         </p:nvSpPr>
         <p:spPr>
           <a:xfrm>
-            <a:off x="5029200" y="2569464"/>
-            <a:ext cx="685800" cy="347472"/>
+            <a:off x="4114800" y="2569464"/>
+            <a:ext cx="548640" cy="347472"/>
           </a:xfrm>
           <a:prstGeom prst="roundRect">
             <a:avLst/>
@@ -5962,8 +5962,8 @@
         </p:nvSpPr>
         <p:spPr>
           <a:xfrm>
-            <a:off x="5715000" y="2569464"/>
-            <a:ext cx="1143000" cy="347472"/>
+            <a:off x="4663440" y="2569464"/>
+            <a:ext cx="960120" cy="347472"/>
           </a:xfrm>
           <a:prstGeom prst="roundRect">
             <a:avLst/>
@@ -6014,8 +6014,8 @@
         </p:nvSpPr>
         <p:spPr>
           <a:xfrm>
-            <a:off x="6858000" y="2569464"/>
-            <a:ext cx="1143000" cy="347472"/>
+            <a:off x="5623560" y="2569464"/>
+            <a:ext cx="960120" cy="347472"/>
           </a:xfrm>
           <a:prstGeom prst="roundRect">
             <a:avLst/>
@@ -6066,8 +6066,8 @@
         </p:nvSpPr>
         <p:spPr>
           <a:xfrm>
-            <a:off x="8001000" y="2569464"/>
-            <a:ext cx="1005840" cy="347472"/>
+            <a:off x="6583680" y="2569464"/>
+            <a:ext cx="777240" cy="347472"/>
           </a:xfrm>
           <a:prstGeom prst="roundRect">
             <a:avLst/>
@@ -6119,7 +6119,7 @@
         <p:spPr>
           <a:xfrm>
             <a:off x="274320" y="2953512"/>
-            <a:ext cx="2468880" cy="347472"/>
+            <a:ext cx="2194560" cy="347472"/>
           </a:xfrm>
           <a:prstGeom prst="roundRect">
             <a:avLst/>
@@ -6170,8 +6170,8 @@
         </p:nvSpPr>
         <p:spPr>
           <a:xfrm>
-            <a:off x="2743200" y="2953512"/>
-            <a:ext cx="1143000" cy="347472"/>
+            <a:off x="2468880" y="2953512"/>
+            <a:ext cx="822960" cy="347472"/>
           </a:xfrm>
           <a:prstGeom prst="roundRect">
             <a:avLst/>
@@ -6222,8 +6222,8 @@
         </p:nvSpPr>
         <p:spPr>
           <a:xfrm>
-            <a:off x="3886200" y="2953512"/>
-            <a:ext cx="1143000" cy="347472"/>
+            <a:off x="3291840" y="2953512"/>
+            <a:ext cx="822960" cy="347472"/>
           </a:xfrm>
           <a:prstGeom prst="roundRect">
             <a:avLst/>
@@ -6274,8 +6274,8 @@
         </p:nvSpPr>
         <p:spPr>
           <a:xfrm>
-            <a:off x="5029200" y="2953512"/>
-            <a:ext cx="685800" cy="347472"/>
+            <a:off x="4114800" y="2953512"/>
+            <a:ext cx="548640" cy="347472"/>
           </a:xfrm>
           <a:prstGeom prst="roundRect">
             <a:avLst/>
@@ -6326,8 +6326,8 @@
         </p:nvSpPr>
         <p:spPr>
           <a:xfrm>
-            <a:off x="5715000" y="2953512"/>
-            <a:ext cx="1143000" cy="347472"/>
+            <a:off x="4663440" y="2953512"/>
+            <a:ext cx="960120" cy="347472"/>
           </a:xfrm>
           <a:prstGeom prst="roundRect">
             <a:avLst/>
@@ -6378,8 +6378,8 @@
         </p:nvSpPr>
         <p:spPr>
           <a:xfrm>
-            <a:off x="6858000" y="2953512"/>
-            <a:ext cx="1143000" cy="347472"/>
+            <a:off x="5623560" y="2953512"/>
+            <a:ext cx="960120" cy="347472"/>
           </a:xfrm>
           <a:prstGeom prst="roundRect">
             <a:avLst/>
@@ -6430,8 +6430,8 @@
         </p:nvSpPr>
         <p:spPr>
           <a:xfrm>
-            <a:off x="8001000" y="2953512"/>
-            <a:ext cx="1005840" cy="347472"/>
+            <a:off x="6583680" y="2953512"/>
+            <a:ext cx="777240" cy="347472"/>
           </a:xfrm>
           <a:prstGeom prst="roundRect">
             <a:avLst/>
@@ -6483,7 +6483,7 @@
         <p:spPr>
           <a:xfrm>
             <a:off x="274320" y="3337560"/>
-            <a:ext cx="2468880" cy="347472"/>
+            <a:ext cx="2194560" cy="347472"/>
           </a:xfrm>
           <a:prstGeom prst="roundRect">
             <a:avLst/>
@@ -6534,8 +6534,8 @@
         </p:nvSpPr>
         <p:spPr>
           <a:xfrm>
-            <a:off x="2743200" y="3337560"/>
-            <a:ext cx="1143000" cy="347472"/>
+            <a:off x="2468880" y="3337560"/>
+            <a:ext cx="822960" cy="347472"/>
           </a:xfrm>
           <a:prstGeom prst="roundRect">
             <a:avLst/>
@@ -6586,8 +6586,8 @@
         </p:nvSpPr>
         <p:spPr>
           <a:xfrm>
-            <a:off x="3886200" y="3337560"/>
-            <a:ext cx="1143000" cy="347472"/>
+            <a:off x="3291840" y="3337560"/>
+            <a:ext cx="822960" cy="347472"/>
           </a:xfrm>
           <a:prstGeom prst="roundRect">
             <a:avLst/>
@@ -6638,8 +6638,8 @@
         </p:nvSpPr>
         <p:spPr>
           <a:xfrm>
-            <a:off x="5029200" y="3337560"/>
-            <a:ext cx="685800" cy="347472"/>
+            <a:off x="4114800" y="3337560"/>
+            <a:ext cx="548640" cy="347472"/>
           </a:xfrm>
           <a:prstGeom prst="roundRect">
             <a:avLst/>
@@ -6690,8 +6690,8 @@
         </p:nvSpPr>
         <p:spPr>
           <a:xfrm>
-            <a:off x="5715000" y="3337560"/>
-            <a:ext cx="1143000" cy="347472"/>
+            <a:off x="4663440" y="3337560"/>
+            <a:ext cx="960120" cy="347472"/>
           </a:xfrm>
           <a:prstGeom prst="roundRect">
             <a:avLst/>
@@ -6742,8 +6742,8 @@
         </p:nvSpPr>
         <p:spPr>
           <a:xfrm>
-            <a:off x="6858000" y="3337560"/>
-            <a:ext cx="1143000" cy="347472"/>
+            <a:off x="5623560" y="3337560"/>
+            <a:ext cx="960120" cy="347472"/>
           </a:xfrm>
           <a:prstGeom prst="roundRect">
             <a:avLst/>
@@ -6794,8 +6794,8 @@
         </p:nvSpPr>
         <p:spPr>
           <a:xfrm>
-            <a:off x="8001000" y="3337560"/>
-            <a:ext cx="1005840" cy="347472"/>
+            <a:off x="6583680" y="3337560"/>
+            <a:ext cx="777240" cy="347472"/>
           </a:xfrm>
           <a:prstGeom prst="roundRect">
             <a:avLst/>
@@ -6847,7 +6847,7 @@
         <p:spPr>
           <a:xfrm>
             <a:off x="274320" y="3721608"/>
-            <a:ext cx="2468880" cy="347472"/>
+            <a:ext cx="2194560" cy="347472"/>
           </a:xfrm>
           <a:prstGeom prst="roundRect">
             <a:avLst/>
@@ -6898,8 +6898,8 @@
         </p:nvSpPr>
         <p:spPr>
           <a:xfrm>
-            <a:off x="2743200" y="3721608"/>
-            <a:ext cx="1143000" cy="347472"/>
+            <a:off x="2468880" y="3721608"/>
+            <a:ext cx="822960" cy="347472"/>
           </a:xfrm>
           <a:prstGeom prst="roundRect">
             <a:avLst/>
@@ -6950,8 +6950,8 @@
         </p:nvSpPr>
         <p:spPr>
           <a:xfrm>
-            <a:off x="3886200" y="3721608"/>
-            <a:ext cx="1143000" cy="347472"/>
+            <a:off x="3291840" y="3721608"/>
+            <a:ext cx="822960" cy="347472"/>
           </a:xfrm>
           <a:prstGeom prst="roundRect">
             <a:avLst/>
@@ -7002,8 +7002,8 @@
         </p:nvSpPr>
         <p:spPr>
           <a:xfrm>
-            <a:off x="5029200" y="3721608"/>
-            <a:ext cx="685800" cy="347472"/>
+            <a:off x="4114800" y="3721608"/>
+            <a:ext cx="548640" cy="347472"/>
           </a:xfrm>
           <a:prstGeom prst="roundRect">
             <a:avLst/>
@@ -7054,8 +7054,8 @@
         </p:nvSpPr>
         <p:spPr>
           <a:xfrm>
-            <a:off x="5715000" y="3721608"/>
-            <a:ext cx="1143000" cy="347472"/>
+            <a:off x="4663440" y="3721608"/>
+            <a:ext cx="960120" cy="347472"/>
           </a:xfrm>
           <a:prstGeom prst="roundRect">
             <a:avLst/>
@@ -7106,8 +7106,8 @@
         </p:nvSpPr>
         <p:spPr>
           <a:xfrm>
-            <a:off x="6858000" y="3721608"/>
-            <a:ext cx="1143000" cy="347472"/>
+            <a:off x="5623560" y="3721608"/>
+            <a:ext cx="960120" cy="347472"/>
           </a:xfrm>
           <a:prstGeom prst="roundRect">
             <a:avLst/>
@@ -7158,8 +7158,8 @@
         </p:nvSpPr>
         <p:spPr>
           <a:xfrm>
-            <a:off x="8001000" y="3721608"/>
-            <a:ext cx="1005840" cy="347472"/>
+            <a:off x="6583680" y="3721608"/>
+            <a:ext cx="777240" cy="347472"/>
           </a:xfrm>
           <a:prstGeom prst="roundRect">
             <a:avLst/>
@@ -7211,7 +7211,7 @@
         <p:spPr>
           <a:xfrm>
             <a:off x="274320" y="4105656"/>
-            <a:ext cx="2468880" cy="347472"/>
+            <a:ext cx="2194560" cy="347472"/>
           </a:xfrm>
           <a:prstGeom prst="roundRect">
             <a:avLst/>
@@ -7262,8 +7262,8 @@
         </p:nvSpPr>
         <p:spPr>
           <a:xfrm>
-            <a:off x="2743200" y="4105656"/>
-            <a:ext cx="1143000" cy="347472"/>
+            <a:off x="2468880" y="4105656"/>
+            <a:ext cx="822960" cy="347472"/>
           </a:xfrm>
           <a:prstGeom prst="roundRect">
             <a:avLst/>
@@ -7314,8 +7314,8 @@
         </p:nvSpPr>
         <p:spPr>
           <a:xfrm>
-            <a:off x="3886200" y="4105656"/>
-            <a:ext cx="1143000" cy="347472"/>
+            <a:off x="3291840" y="4105656"/>
+            <a:ext cx="822960" cy="347472"/>
           </a:xfrm>
           <a:prstGeom prst="roundRect">
             <a:avLst/>
@@ -7366,8 +7366,8 @@
         </p:nvSpPr>
         <p:spPr>
           <a:xfrm>
-            <a:off x="5029200" y="4105656"/>
-            <a:ext cx="685800" cy="347472"/>
+            <a:off x="4114800" y="4105656"/>
+            <a:ext cx="548640" cy="347472"/>
           </a:xfrm>
           <a:prstGeom prst="roundRect">
             <a:avLst/>
@@ -7418,8 +7418,8 @@
         </p:nvSpPr>
         <p:spPr>
           <a:xfrm>
-            <a:off x="5715000" y="4105656"/>
-            <a:ext cx="1143000" cy="347472"/>
+            <a:off x="4663440" y="4105656"/>
+            <a:ext cx="960120" cy="347472"/>
           </a:xfrm>
           <a:prstGeom prst="roundRect">
             <a:avLst/>
@@ -7470,8 +7470,8 @@
         </p:nvSpPr>
         <p:spPr>
           <a:xfrm>
-            <a:off x="6858000" y="4105656"/>
-            <a:ext cx="1143000" cy="347472"/>
+            <a:off x="5623560" y="4105656"/>
+            <a:ext cx="960120" cy="347472"/>
           </a:xfrm>
           <a:prstGeom prst="roundRect">
             <a:avLst/>
@@ -7522,8 +7522,8 @@
         </p:nvSpPr>
         <p:spPr>
           <a:xfrm>
-            <a:off x="8001000" y="4105656"/>
-            <a:ext cx="1005840" cy="347472"/>
+            <a:off x="6583680" y="4105656"/>
+            <a:ext cx="777240" cy="347472"/>
           </a:xfrm>
           <a:prstGeom prst="roundRect">
             <a:avLst/>
@@ -7575,7 +7575,7 @@
         <p:spPr>
           <a:xfrm>
             <a:off x="274320" y="4489704"/>
-            <a:ext cx="2468880" cy="347472"/>
+            <a:ext cx="2194560" cy="347472"/>
           </a:xfrm>
           <a:prstGeom prst="roundRect">
             <a:avLst/>
@@ -7626,8 +7626,8 @@
         </p:nvSpPr>
         <p:spPr>
           <a:xfrm>
-            <a:off x="2743200" y="4489704"/>
-            <a:ext cx="1143000" cy="347472"/>
+            <a:off x="2468880" y="4489704"/>
+            <a:ext cx="822960" cy="347472"/>
           </a:xfrm>
           <a:prstGeom prst="roundRect">
             <a:avLst/>
@@ -7678,8 +7678,8 @@
         </p:nvSpPr>
         <p:spPr>
           <a:xfrm>
-            <a:off x="3886200" y="4489704"/>
-            <a:ext cx="1143000" cy="347472"/>
+            <a:off x="3291840" y="4489704"/>
+            <a:ext cx="822960" cy="347472"/>
           </a:xfrm>
           <a:prstGeom prst="roundRect">
             <a:avLst/>
@@ -7730,8 +7730,8 @@
         </p:nvSpPr>
         <p:spPr>
           <a:xfrm>
-            <a:off x="5029200" y="4489704"/>
-            <a:ext cx="685800" cy="347472"/>
+            <a:off x="4114800" y="4489704"/>
+            <a:ext cx="548640" cy="347472"/>
           </a:xfrm>
           <a:prstGeom prst="roundRect">
             <a:avLst/>
@@ -7782,8 +7782,8 @@
         </p:nvSpPr>
         <p:spPr>
           <a:xfrm>
-            <a:off x="5715000" y="4489704"/>
-            <a:ext cx="1143000" cy="347472"/>
+            <a:off x="4663440" y="4489704"/>
+            <a:ext cx="960120" cy="347472"/>
           </a:xfrm>
           <a:prstGeom prst="roundRect">
             <a:avLst/>
@@ -7834,8 +7834,8 @@
         </p:nvSpPr>
         <p:spPr>
           <a:xfrm>
-            <a:off x="6858000" y="4489704"/>
-            <a:ext cx="1143000" cy="347472"/>
+            <a:off x="5623560" y="4489704"/>
+            <a:ext cx="960120" cy="347472"/>
           </a:xfrm>
           <a:prstGeom prst="roundRect">
             <a:avLst/>
@@ -7886,8 +7886,8 @@
         </p:nvSpPr>
         <p:spPr>
           <a:xfrm>
-            <a:off x="8001000" y="4489704"/>
-            <a:ext cx="1005840" cy="347472"/>
+            <a:off x="6583680" y="4489704"/>
+            <a:ext cx="777240" cy="347472"/>
           </a:xfrm>
           <a:prstGeom prst="roundRect">
             <a:avLst/>
@@ -7939,7 +7939,7 @@
         <p:spPr>
           <a:xfrm>
             <a:off x="274320" y="4873752"/>
-            <a:ext cx="2468880" cy="347472"/>
+            <a:ext cx="2194560" cy="347472"/>
           </a:xfrm>
           <a:prstGeom prst="roundRect">
             <a:avLst/>
@@ -7990,8 +7990,8 @@
         </p:nvSpPr>
         <p:spPr>
           <a:xfrm>
-            <a:off x="2743200" y="4873752"/>
-            <a:ext cx="1143000" cy="347472"/>
+            <a:off x="2468880" y="4873752"/>
+            <a:ext cx="822960" cy="347472"/>
           </a:xfrm>
           <a:prstGeom prst="roundRect">
             <a:avLst/>
@@ -8042,8 +8042,8 @@
         </p:nvSpPr>
         <p:spPr>
           <a:xfrm>
-            <a:off x="3886200" y="4873752"/>
-            <a:ext cx="1143000" cy="347472"/>
+            <a:off x="3291840" y="4873752"/>
+            <a:ext cx="822960" cy="347472"/>
           </a:xfrm>
           <a:prstGeom prst="roundRect">
             <a:avLst/>
@@ -8094,8 +8094,8 @@
         </p:nvSpPr>
         <p:spPr>
           <a:xfrm>
-            <a:off x="5029200" y="4873752"/>
-            <a:ext cx="685800" cy="347472"/>
+            <a:off x="4114800" y="4873752"/>
+            <a:ext cx="548640" cy="347472"/>
           </a:xfrm>
           <a:prstGeom prst="roundRect">
             <a:avLst/>
@@ -8146,8 +8146,8 @@
         </p:nvSpPr>
         <p:spPr>
           <a:xfrm>
-            <a:off x="5715000" y="4873752"/>
-            <a:ext cx="1143000" cy="347472"/>
+            <a:off x="4663440" y="4873752"/>
+            <a:ext cx="960120" cy="347472"/>
           </a:xfrm>
           <a:prstGeom prst="roundRect">
             <a:avLst/>
@@ -8198,8 +8198,8 @@
         </p:nvSpPr>
         <p:spPr>
           <a:xfrm>
-            <a:off x="6858000" y="4873752"/>
-            <a:ext cx="1143000" cy="347472"/>
+            <a:off x="5623560" y="4873752"/>
+            <a:ext cx="960120" cy="347472"/>
           </a:xfrm>
           <a:prstGeom prst="roundRect">
             <a:avLst/>
@@ -8250,8 +8250,8 @@
         </p:nvSpPr>
         <p:spPr>
           <a:xfrm>
-            <a:off x="8001000" y="4873752"/>
-            <a:ext cx="1005840" cy="347472"/>
+            <a:off x="6583680" y="4873752"/>
+            <a:ext cx="777240" cy="347472"/>
           </a:xfrm>
           <a:prstGeom prst="roundRect">
             <a:avLst/>
@@ -8303,7 +8303,7 @@
         <p:spPr>
           <a:xfrm>
             <a:off x="274320" y="5257800"/>
-            <a:ext cx="2468880" cy="347472"/>
+            <a:ext cx="2194560" cy="347472"/>
           </a:xfrm>
           <a:prstGeom prst="roundRect">
             <a:avLst/>
@@ -8354,8 +8354,8 @@
         </p:nvSpPr>
         <p:spPr>
           <a:xfrm>
-            <a:off x="2743200" y="5257800"/>
-            <a:ext cx="1143000" cy="347472"/>
+            <a:off x="2468880" y="5257800"/>
+            <a:ext cx="822960" cy="347472"/>
           </a:xfrm>
           <a:prstGeom prst="roundRect">
             <a:avLst/>
@@ -8406,8 +8406,8 @@
         </p:nvSpPr>
         <p:spPr>
           <a:xfrm>
-            <a:off x="3886200" y="5257800"/>
-            <a:ext cx="1143000" cy="347472"/>
+            <a:off x="3291840" y="5257800"/>
+            <a:ext cx="822960" cy="347472"/>
           </a:xfrm>
           <a:prstGeom prst="roundRect">
             <a:avLst/>
@@ -8458,8 +8458,8 @@
         </p:nvSpPr>
         <p:spPr>
           <a:xfrm>
-            <a:off x="5029200" y="5257800"/>
-            <a:ext cx="685800" cy="347472"/>
+            <a:off x="4114800" y="5257800"/>
+            <a:ext cx="548640" cy="347472"/>
           </a:xfrm>
           <a:prstGeom prst="roundRect">
             <a:avLst/>
@@ -8510,8 +8510,8 @@
         </p:nvSpPr>
         <p:spPr>
           <a:xfrm>
-            <a:off x="5715000" y="5257800"/>
-            <a:ext cx="1143000" cy="347472"/>
+            <a:off x="4663440" y="5257800"/>
+            <a:ext cx="960120" cy="347472"/>
           </a:xfrm>
           <a:prstGeom prst="roundRect">
             <a:avLst/>
@@ -8562,8 +8562,8 @@
         </p:nvSpPr>
         <p:spPr>
           <a:xfrm>
-            <a:off x="6858000" y="5257800"/>
-            <a:ext cx="1143000" cy="347472"/>
+            <a:off x="5623560" y="5257800"/>
+            <a:ext cx="960120" cy="347472"/>
           </a:xfrm>
           <a:prstGeom prst="roundRect">
             <a:avLst/>
@@ -8614,8 +8614,8 @@
         </p:nvSpPr>
         <p:spPr>
           <a:xfrm>
-            <a:off x="8001000" y="5257800"/>
-            <a:ext cx="1005840" cy="347472"/>
+            <a:off x="6583680" y="5257800"/>
+            <a:ext cx="777240" cy="347472"/>
           </a:xfrm>
           <a:prstGeom prst="roundRect">
             <a:avLst/>
@@ -8667,7 +8667,7 @@
         <p:spPr>
           <a:xfrm>
             <a:off x="274320" y="5641848"/>
-            <a:ext cx="2468880" cy="347472"/>
+            <a:ext cx="2194560" cy="347472"/>
           </a:xfrm>
           <a:prstGeom prst="roundRect">
             <a:avLst/>
@@ -8718,8 +8718,8 @@
         </p:nvSpPr>
         <p:spPr>
           <a:xfrm>
-            <a:off x="2743200" y="5641848"/>
-            <a:ext cx="1143000" cy="347472"/>
+            <a:off x="2468880" y="5641848"/>
+            <a:ext cx="822960" cy="347472"/>
           </a:xfrm>
           <a:prstGeom prst="roundRect">
             <a:avLst/>
@@ -8770,8 +8770,8 @@
         </p:nvSpPr>
         <p:spPr>
           <a:xfrm>
-            <a:off x="3886200" y="5641848"/>
-            <a:ext cx="1143000" cy="347472"/>
+            <a:off x="3291840" y="5641848"/>
+            <a:ext cx="822960" cy="347472"/>
           </a:xfrm>
           <a:prstGeom prst="roundRect">
             <a:avLst/>
@@ -8822,8 +8822,8 @@
         </p:nvSpPr>
         <p:spPr>
           <a:xfrm>
-            <a:off x="5029200" y="5641848"/>
-            <a:ext cx="685800" cy="347472"/>
+            <a:off x="4114800" y="5641848"/>
+            <a:ext cx="548640" cy="347472"/>
           </a:xfrm>
           <a:prstGeom prst="roundRect">
             <a:avLst/>
@@ -8874,8 +8874,8 @@
         </p:nvSpPr>
         <p:spPr>
           <a:xfrm>
-            <a:off x="5715000" y="5641848"/>
-            <a:ext cx="1143000" cy="347472"/>
+            <a:off x="4663440" y="5641848"/>
+            <a:ext cx="960120" cy="347472"/>
           </a:xfrm>
           <a:prstGeom prst="roundRect">
             <a:avLst/>
@@ -8926,8 +8926,8 @@
         </p:nvSpPr>
         <p:spPr>
           <a:xfrm>
-            <a:off x="6858000" y="5641848"/>
-            <a:ext cx="1143000" cy="347472"/>
+            <a:off x="5623560" y="5641848"/>
+            <a:ext cx="960120" cy="347472"/>
           </a:xfrm>
           <a:prstGeom prst="roundRect">
             <a:avLst/>
@@ -8978,8 +8978,8 @@
         </p:nvSpPr>
         <p:spPr>
           <a:xfrm>
-            <a:off x="8001000" y="5641848"/>
-            <a:ext cx="1005840" cy="347472"/>
+            <a:off x="6583680" y="5641848"/>
+            <a:ext cx="777240" cy="347472"/>
           </a:xfrm>
           <a:prstGeom prst="roundRect">
             <a:avLst/>
@@ -9031,7 +9031,7 @@
         <p:spPr>
           <a:xfrm>
             <a:off x="274320" y="6025896"/>
-            <a:ext cx="2468880" cy="347472"/>
+            <a:ext cx="2194560" cy="347472"/>
           </a:xfrm>
           <a:prstGeom prst="roundRect">
             <a:avLst/>
@@ -9082,8 +9082,8 @@
         </p:nvSpPr>
         <p:spPr>
           <a:xfrm>
-            <a:off x="2743200" y="6025896"/>
-            <a:ext cx="1143000" cy="347472"/>
+            <a:off x="2468880" y="6025896"/>
+            <a:ext cx="822960" cy="347472"/>
           </a:xfrm>
           <a:prstGeom prst="roundRect">
             <a:avLst/>
@@ -9134,8 +9134,8 @@
         </p:nvSpPr>
         <p:spPr>
           <a:xfrm>
-            <a:off x="3886200" y="6025896"/>
-            <a:ext cx="1143000" cy="347472"/>
+            <a:off x="3291840" y="6025896"/>
+            <a:ext cx="822960" cy="347472"/>
           </a:xfrm>
           <a:prstGeom prst="roundRect">
             <a:avLst/>
@@ -9186,8 +9186,8 @@
         </p:nvSpPr>
         <p:spPr>
           <a:xfrm>
-            <a:off x="5029200" y="6025896"/>
-            <a:ext cx="685800" cy="347472"/>
+            <a:off x="4114800" y="6025896"/>
+            <a:ext cx="548640" cy="347472"/>
           </a:xfrm>
           <a:prstGeom prst="roundRect">
             <a:avLst/>
@@ -9238,8 +9238,8 @@
         </p:nvSpPr>
         <p:spPr>
           <a:xfrm>
-            <a:off x="5715000" y="6025896"/>
-            <a:ext cx="1143000" cy="347472"/>
+            <a:off x="4663440" y="6025896"/>
+            <a:ext cx="960120" cy="347472"/>
           </a:xfrm>
           <a:prstGeom prst="roundRect">
             <a:avLst/>
@@ -9290,8 +9290,8 @@
         </p:nvSpPr>
         <p:spPr>
           <a:xfrm>
-            <a:off x="6858000" y="6025896"/>
-            <a:ext cx="1143000" cy="347472"/>
+            <a:off x="5623560" y="6025896"/>
+            <a:ext cx="960120" cy="347472"/>
           </a:xfrm>
           <a:prstGeom prst="roundRect">
             <a:avLst/>
@@ -9342,8 +9342,8 @@
         </p:nvSpPr>
         <p:spPr>
           <a:xfrm>
-            <a:off x="8001000" y="6025896"/>
-            <a:ext cx="1005840" cy="347472"/>
+            <a:off x="6583680" y="6025896"/>
+            <a:ext cx="777240" cy="347472"/>
           </a:xfrm>
           <a:prstGeom prst="roundRect">
             <a:avLst/>
@@ -9395,7 +9395,7 @@
         <p:spPr>
           <a:xfrm>
             <a:off x="274320" y="6428232"/>
-            <a:ext cx="2468880" cy="411480"/>
+            <a:ext cx="2194560" cy="411480"/>
           </a:xfrm>
           <a:prstGeom prst="roundRect">
             <a:avLst/>
@@ -9446,8 +9446,8 @@
         </p:nvSpPr>
         <p:spPr>
           <a:xfrm>
-            <a:off x="2743200" y="6428232"/>
-            <a:ext cx="1143000" cy="411480"/>
+            <a:off x="2468880" y="6428232"/>
+            <a:ext cx="822960" cy="411480"/>
           </a:xfrm>
           <a:prstGeom prst="roundRect">
             <a:avLst/>
@@ -9490,8 +9490,8 @@
         </p:nvSpPr>
         <p:spPr>
           <a:xfrm>
-            <a:off x="3886200" y="6428232"/>
-            <a:ext cx="1143000" cy="411480"/>
+            <a:off x="3291840" y="6428232"/>
+            <a:ext cx="822960" cy="411480"/>
           </a:xfrm>
           <a:prstGeom prst="roundRect">
             <a:avLst/>
@@ -9534,8 +9534,8 @@
         </p:nvSpPr>
         <p:spPr>
           <a:xfrm>
-            <a:off x="5029200" y="6428232"/>
-            <a:ext cx="685800" cy="411480"/>
+            <a:off x="4114800" y="6428232"/>
+            <a:ext cx="548640" cy="411480"/>
           </a:xfrm>
           <a:prstGeom prst="roundRect">
             <a:avLst/>
@@ -9578,8 +9578,8 @@
         </p:nvSpPr>
         <p:spPr>
           <a:xfrm>
-            <a:off x="5715000" y="6428232"/>
-            <a:ext cx="1143000" cy="411480"/>
+            <a:off x="4663440" y="6428232"/>
+            <a:ext cx="960120" cy="411480"/>
           </a:xfrm>
           <a:prstGeom prst="roundRect">
             <a:avLst/>
@@ -9630,8 +9630,8 @@
         </p:nvSpPr>
         <p:spPr>
           <a:xfrm>
-            <a:off x="6858000" y="6428232"/>
-            <a:ext cx="1143000" cy="411480"/>
+            <a:off x="5623560" y="6428232"/>
+            <a:ext cx="960120" cy="411480"/>
           </a:xfrm>
           <a:prstGeom prst="roundRect">
             <a:avLst/>
@@ -9682,8 +9682,8 @@
         </p:nvSpPr>
         <p:spPr>
           <a:xfrm>
-            <a:off x="8001000" y="6428232"/>
-            <a:ext cx="1005840" cy="411480"/>
+            <a:off x="6583680" y="6428232"/>
+            <a:ext cx="777240" cy="411480"/>
           </a:xfrm>
           <a:prstGeom prst="roundRect">
             <a:avLst/>
@@ -9734,8 +9734,8 @@
         </p:nvSpPr>
         <p:spPr>
           <a:xfrm>
-            <a:off x="8412480" y="1417320"/>
-            <a:ext cx="3474720" cy="3840480"/>
+            <a:off x="7498079" y="1417320"/>
+            <a:ext cx="4389120" cy="3474720"/>
           </a:xfrm>
           <a:prstGeom prst="roundRect">
             <a:avLst/>
@@ -9793,8 +9793,8 @@
         </p:nvSpPr>
         <p:spPr>
           <a:xfrm>
-            <a:off x="8412480" y="5394960"/>
-            <a:ext cx="3474720" cy="1097280"/>
+            <a:off x="7498079" y="5029200"/>
+            <a:ext cx="4389120" cy="1188720"/>
           </a:xfrm>
           <a:prstGeom prst="roundRect">
             <a:avLst/>
@@ -9827,15 +9827,14 @@
           <a:p>
             <a:pPr algn="ctr"/>
             <a:r>
-              <a:rPr sz="1300" b="1">
+              <a:rPr sz="1400" b="1">
                 <a:solidFill>
                   <a:srgbClr val="FFFFFF"/>
                 </a:solidFill>
               </a:rPr>
               <a:t>Additional Savings:
 +$1.2–3.5M/year
-Informatica license
-elimination</a:t>
+Informatica license elimination</a:t>
             </a:r>
           </a:p>
         </p:txBody>
@@ -18587,8 +18586,8 @@
         </p:nvSpPr>
         <p:spPr>
           <a:xfrm>
-            <a:off x="8229600" y="1463040"/>
-            <a:ext cx="2377440" cy="1371600"/>
+            <a:off x="7955279" y="1463040"/>
+            <a:ext cx="2011680" cy="1371600"/>
           </a:xfrm>
           <a:prstGeom prst="roundRect">
             <a:avLst/>
@@ -18631,8 +18630,8 @@
         </p:nvSpPr>
         <p:spPr>
           <a:xfrm>
-            <a:off x="8321040" y="1600200"/>
-            <a:ext cx="2194560" cy="731520"/>
+            <a:off x="8000999" y="1600200"/>
+            <a:ext cx="1920240" cy="731520"/>
           </a:xfrm>
           <a:prstGeom prst="rect">
             <a:avLst/>
@@ -18647,7 +18646,7 @@
           <a:p>
             <a:pPr algn="ctr"/>
             <a:r>
-              <a:rPr sz="3600" b="1">
+              <a:rPr sz="3200" b="1">
                 <a:solidFill>
                   <a:srgbClr val="FFFFFF"/>
                 </a:solidFill>
@@ -18665,8 +18664,8 @@
         </p:nvSpPr>
         <p:spPr>
           <a:xfrm>
-            <a:off x="8321040" y="2240280"/>
-            <a:ext cx="2194560" cy="457200"/>
+            <a:off x="8000999" y="2240280"/>
+            <a:ext cx="1920240" cy="457200"/>
           </a:xfrm>
           <a:prstGeom prst="rect">
             <a:avLst/>
@@ -18681,7 +18680,7 @@
           <a:p>
             <a:pPr algn="ctr"/>
             <a:r>
-              <a:rPr sz="1300" b="0">
+              <a:rPr sz="1200" b="0">
                 <a:solidFill>
                   <a:srgbClr val="FFFFFF"/>
                 </a:solidFill>
@@ -18700,8 +18699,8 @@
         </p:nvSpPr>
         <p:spPr>
           <a:xfrm>
-            <a:off x="8229600" y="3108960"/>
-            <a:ext cx="2377440" cy="1371600"/>
+            <a:off x="7955279" y="3108960"/>
+            <a:ext cx="2011680" cy="1371600"/>
           </a:xfrm>
           <a:prstGeom prst="roundRect">
             <a:avLst/>
@@ -18744,8 +18743,8 @@
         </p:nvSpPr>
         <p:spPr>
           <a:xfrm>
-            <a:off x="8321040" y="3246120"/>
-            <a:ext cx="2194560" cy="731520"/>
+            <a:off x="8000999" y="3246120"/>
+            <a:ext cx="1920240" cy="731520"/>
           </a:xfrm>
           <a:prstGeom prst="rect">
             <a:avLst/>
@@ -18760,7 +18759,7 @@
           <a:p>
             <a:pPr algn="ctr"/>
             <a:r>
-              <a:rPr sz="3600" b="1">
+              <a:rPr sz="3200" b="1">
                 <a:solidFill>
                   <a:srgbClr val="FFFFFF"/>
                 </a:solidFill>
@@ -18778,8 +18777,8 @@
         </p:nvSpPr>
         <p:spPr>
           <a:xfrm>
-            <a:off x="8321040" y="3886200"/>
-            <a:ext cx="2194560" cy="457200"/>
+            <a:off x="8000999" y="3886200"/>
+            <a:ext cx="1920240" cy="457200"/>
           </a:xfrm>
           <a:prstGeom prst="rect">
             <a:avLst/>
@@ -18794,7 +18793,7 @@
           <a:p>
             <a:pPr algn="ctr"/>
             <a:r>
-              <a:rPr sz="1300" b="0">
+              <a:rPr sz="1200" b="0">
                 <a:solidFill>
                   <a:srgbClr val="FFFFFF"/>
                 </a:solidFill>
@@ -18813,8 +18812,8 @@
         </p:nvSpPr>
         <p:spPr>
           <a:xfrm>
-            <a:off x="8229600" y="4754880"/>
-            <a:ext cx="2377440" cy="1371600"/>
+            <a:off x="7955279" y="4754880"/>
+            <a:ext cx="2011680" cy="1371600"/>
           </a:xfrm>
           <a:prstGeom prst="roundRect">
             <a:avLst/>
@@ -18857,8 +18856,8 @@
         </p:nvSpPr>
         <p:spPr>
           <a:xfrm>
-            <a:off x="8321040" y="4892040"/>
-            <a:ext cx="2194560" cy="731520"/>
+            <a:off x="8000999" y="4892040"/>
+            <a:ext cx="1920240" cy="731520"/>
           </a:xfrm>
           <a:prstGeom prst="rect">
             <a:avLst/>
@@ -18873,7 +18872,7 @@
           <a:p>
             <a:pPr algn="ctr"/>
             <a:r>
-              <a:rPr sz="3600" b="1">
+              <a:rPr sz="3200" b="1">
                 <a:solidFill>
                   <a:srgbClr val="FFFFFF"/>
                 </a:solidFill>
@@ -18891,8 +18890,8 @@
         </p:nvSpPr>
         <p:spPr>
           <a:xfrm>
-            <a:off x="8321040" y="5532120"/>
-            <a:ext cx="2194560" cy="457200"/>
+            <a:off x="8000999" y="5532120"/>
+            <a:ext cx="1920240" cy="457200"/>
           </a:xfrm>
           <a:prstGeom prst="rect">
             <a:avLst/>
@@ -18907,7 +18906,7 @@
           <a:p>
             <a:pPr algn="ctr"/>
             <a:r>
-              <a:rPr sz="1300" b="0">
+              <a:rPr sz="1200" b="0">
                 <a:solidFill>
                   <a:srgbClr val="FFFFFF"/>
                 </a:solidFill>
@@ -18926,8 +18925,8 @@
         </p:nvSpPr>
         <p:spPr>
           <a:xfrm>
-            <a:off x="10789920" y="1463040"/>
-            <a:ext cx="2377440" cy="1371600"/>
+            <a:off x="10058400" y="1463040"/>
+            <a:ext cx="2011680" cy="1371600"/>
           </a:xfrm>
           <a:prstGeom prst="roundRect">
             <a:avLst/>
@@ -18970,8 +18969,8 @@
         </p:nvSpPr>
         <p:spPr>
           <a:xfrm>
-            <a:off x="10881360" y="1600200"/>
-            <a:ext cx="2194560" cy="731520"/>
+            <a:off x="10104120" y="1600200"/>
+            <a:ext cx="1920240" cy="731520"/>
           </a:xfrm>
           <a:prstGeom prst="rect">
             <a:avLst/>
@@ -18986,7 +18985,7 @@
           <a:p>
             <a:pPr algn="ctr"/>
             <a:r>
-              <a:rPr sz="3600" b="1">
+              <a:rPr sz="3200" b="1">
                 <a:solidFill>
                   <a:srgbClr val="FFFFFF"/>
                 </a:solidFill>
@@ -19004,8 +19003,8 @@
         </p:nvSpPr>
         <p:spPr>
           <a:xfrm>
-            <a:off x="10881360" y="2240280"/>
-            <a:ext cx="2194560" cy="457200"/>
+            <a:off x="10104120" y="2240280"/>
+            <a:ext cx="1920240" cy="457200"/>
           </a:xfrm>
           <a:prstGeom prst="rect">
             <a:avLst/>
@@ -19020,7 +19019,7 @@
           <a:p>
             <a:pPr algn="ctr"/>
             <a:r>
-              <a:rPr sz="1300" b="0">
+              <a:rPr sz="1200" b="0">
                 <a:solidFill>
                   <a:srgbClr val="FFFFFF"/>
                 </a:solidFill>
@@ -19039,8 +19038,8 @@
         </p:nvSpPr>
         <p:spPr>
           <a:xfrm>
-            <a:off x="10789920" y="3108960"/>
-            <a:ext cx="2377440" cy="1371600"/>
+            <a:off x="10058400" y="3108960"/>
+            <a:ext cx="2011680" cy="1371600"/>
           </a:xfrm>
           <a:prstGeom prst="roundRect">
             <a:avLst/>
@@ -19083,8 +19082,8 @@
         </p:nvSpPr>
         <p:spPr>
           <a:xfrm>
-            <a:off x="10881360" y="3246120"/>
-            <a:ext cx="2194560" cy="731520"/>
+            <a:off x="10104120" y="3246120"/>
+            <a:ext cx="1920240" cy="731520"/>
           </a:xfrm>
           <a:prstGeom prst="rect">
             <a:avLst/>
@@ -19099,7 +19098,7 @@
           <a:p>
             <a:pPr algn="ctr"/>
             <a:r>
-              <a:rPr sz="3600" b="1">
+              <a:rPr sz="3200" b="1">
                 <a:solidFill>
                   <a:srgbClr val="FFFFFF"/>
                 </a:solidFill>
@@ -19117,8 +19116,8 @@
         </p:nvSpPr>
         <p:spPr>
           <a:xfrm>
-            <a:off x="10881360" y="3886200"/>
-            <a:ext cx="2194560" cy="457200"/>
+            <a:off x="10104120" y="3886200"/>
+            <a:ext cx="1920240" cy="457200"/>
           </a:xfrm>
           <a:prstGeom prst="rect">
             <a:avLst/>
@@ -19133,7 +19132,7 @@
           <a:p>
             <a:pPr algn="ctr"/>
             <a:r>
-              <a:rPr sz="1300" b="0">
+              <a:rPr sz="1200" b="0">
                 <a:solidFill>
                   <a:srgbClr val="FFFFFF"/>
                 </a:solidFill>
@@ -19152,8 +19151,8 @@
         </p:nvSpPr>
         <p:spPr>
           <a:xfrm>
-            <a:off x="10789920" y="4754880"/>
-            <a:ext cx="2377440" cy="1371600"/>
+            <a:off x="10058400" y="4754880"/>
+            <a:ext cx="2011680" cy="1371600"/>
           </a:xfrm>
           <a:prstGeom prst="roundRect">
             <a:avLst/>
@@ -19196,8 +19195,8 @@
         </p:nvSpPr>
         <p:spPr>
           <a:xfrm>
-            <a:off x="10881360" y="4892040"/>
-            <a:ext cx="2194560" cy="731520"/>
+            <a:off x="10104120" y="4892040"/>
+            <a:ext cx="1920240" cy="731520"/>
           </a:xfrm>
           <a:prstGeom prst="rect">
             <a:avLst/>
@@ -19212,7 +19211,7 @@
           <a:p>
             <a:pPr algn="ctr"/>
             <a:r>
-              <a:rPr sz="3600" b="1">
+              <a:rPr sz="3200" b="1">
                 <a:solidFill>
                   <a:srgbClr val="FFFFFF"/>
                 </a:solidFill>
@@ -19230,8 +19229,8 @@
         </p:nvSpPr>
         <p:spPr>
           <a:xfrm>
-            <a:off x="10881360" y="5532120"/>
-            <a:ext cx="2194560" cy="457200"/>
+            <a:off x="10104120" y="5532120"/>
+            <a:ext cx="1920240" cy="457200"/>
           </a:xfrm>
           <a:prstGeom prst="rect">
             <a:avLst/>
@@ -19246,7 +19245,7 @@
           <a:p>
             <a:pPr algn="ctr"/>
             <a:r>
-              <a:rPr sz="1300" b="0">
+              <a:rPr sz="1200" b="0">
                 <a:solidFill>
                   <a:srgbClr val="FFFFFF"/>
                 </a:solidFill>

</xml_diff>